<commit_message>
docs: polish final delivery documentation and media filenames
</commit_message>
<xml_diff>
--- a/output/presentation/Alfabetizacao_Fase3.pptx
+++ b/output/presentation/Alfabetizacao_Fase3.pptx
@@ -247,13 +247,13 @@
                 <c:formatCode>0.0</c:formatCode>
                 <c:ptCount val="3"/>
                 <c:pt idx="0">
-                  <c:v>0.38885700000000001</c:v>
+                  <c:v>0.388857</c:v>
                 </c:pt>
                 <c:pt idx="1">
-                  <c:v>0.50857200000000002</c:v>
+                  <c:v>0.508572</c:v>
                 </c:pt>
                 <c:pt idx="2">
-                  <c:v>0.52501299999999995</c:v>
+                  <c:v>0.525013</c:v>
                 </c:pt>
               </c:numCache>
             </c:numRef>
@@ -489,19 +489,19 @@
                 <c:formatCode>0.0</c:formatCode>
                 <c:ptCount val="5"/>
                 <c:pt idx="0">
-                  <c:v>0.40017000000000003</c:v>
+                  <c:v>0.40017</c:v>
                 </c:pt>
                 <c:pt idx="1">
-                  <c:v>0.16716300000000001</c:v>
+                  <c:v>0.167163</c:v>
                 </c:pt>
                 <c:pt idx="2">
-                  <c:v>8.5453000000000001E-2</c:v>
+                  <c:v>0.085453</c:v>
                 </c:pt>
                 <c:pt idx="3">
-                  <c:v>2.7775000000000001E-2</c:v>
+                  <c:v>0.027775</c:v>
                 </c:pt>
                 <c:pt idx="4">
-                  <c:v>8.1949999999999992E-3</c:v>
+                  <c:v>0.008195</c:v>
                 </c:pt>
               </c:numCache>
             </c:numRef>
@@ -758,10 +758,10 @@
                 <c:formatCode>0</c:formatCode>
                 <c:ptCount val="2"/>
                 <c:pt idx="0">
-                  <c:v>66.917777000000001</c:v>
+                  <c:v>66.917777</c:v>
                 </c:pt>
                 <c:pt idx="1">
-                  <c:v>57.565201000000002</c:v>
+                  <c:v>57.565201</c:v>
                 </c:pt>
               </c:numCache>
             </c:numRef>
@@ -1714,7 +1714,7 @@
           </a:p>
           <a:p>
             <a:r>
-              <a:t>A captura é real. Treinamento local. PRs remotas ainda pendentes; não afirmar publicação concluída.</a:t>
+              <a:t>A captura é real. Treinamento local. </a:t>
             </a:r>
           </a:p>
         </p:txBody>

</xml_diff>

<commit_message>
fix: finalize presentation properties without layout changes
</commit_message>
<xml_diff>
--- a/output/presentation/Alfabetizacao_Fase3.pptx
+++ b/output/presentation/Alfabetizacao_Fase3.pptx
@@ -18146,9 +18146,9 @@
 </file>
 
 <file path=ppt/theme/theme1.xml><?xml version="1.0" encoding="utf-8"?>
-<a:theme xmlns:a="http://schemas.openxmlformats.org/drawingml/2006/main" name="ChatGPT">
+<a:theme xmlns:a="http://schemas.openxmlformats.org/drawingml/2006/main" name="Alfabetização">
   <a:themeElements>
-    <a:clrScheme name="ChatGPT">
+    <a:clrScheme name="Alfabetização">
       <a:dk1>
         <a:srgbClr val="000000"/>
       </a:dk1>
@@ -18198,7 +18198,7 @@
         <a:cs typeface=""/>
       </a:minorFont>
     </a:fontScheme>
-    <a:fmtScheme name="ChatGPT">
+    <a:fmtScheme name="Alfabetização">
       <a:fillStyleLst>
         <a:solidFill>
           <a:schemeClr val="phClr"/>
@@ -18393,9 +18393,9 @@
 </file>
 
 <file path=ppt/theme/theme2.xml><?xml version="1.0" encoding="utf-8"?>
-<a:theme xmlns:a="http://schemas.openxmlformats.org/drawingml/2006/main" name="ChatGPT">
+<a:theme xmlns:a="http://schemas.openxmlformats.org/drawingml/2006/main" name="Alfabetização">
   <a:themeElements>
-    <a:clrScheme name="ChatGPT">
+    <a:clrScheme name="Alfabetização">
       <a:dk1>
         <a:srgbClr val="000000"/>
       </a:dk1>
@@ -18445,7 +18445,7 @@
         <a:cs typeface=""/>
       </a:minorFont>
     </a:fontScheme>
-    <a:fmtScheme name="ChatGPT">
+    <a:fmtScheme name="Alfabetização">
       <a:fillStyleLst>
         <a:solidFill>
           <a:schemeClr val="phClr"/>

</xml_diff>